<commit_message>
Even more game theory
</commit_message>
<xml_diff>
--- a/Reading Course/Presentations/More Game Theory.pptx
+++ b/Reading Course/Presentations/More Game Theory.pptx
@@ -160,17 +160,10 @@
   <pc:docChgLst>
     <pc:chgData name="Jacob Wyngaard" userId="6181fcd471e98458" providerId="LiveId" clId="{788BA123-62C9-4DDC-86E5-A6BCA4600216}"/>
     <pc:docChg chg="undo custSel addSld delSld modSld sldOrd">
-      <pc:chgData name="Jacob Wyngaard" userId="6181fcd471e98458" providerId="LiveId" clId="{788BA123-62C9-4DDC-86E5-A6BCA4600216}" dt="2026-02-17T03:13:41.011" v="2959" actId="14100"/>
+      <pc:chgData name="Jacob Wyngaard" userId="6181fcd471e98458" providerId="LiveId" clId="{788BA123-62C9-4DDC-86E5-A6BCA4600216}" dt="2026-02-23T16:27:20.536" v="2960" actId="1076"/>
       <pc:docMkLst>
         <pc:docMk/>
       </pc:docMkLst>
-      <pc:sldChg chg="del">
-        <pc:chgData name="Jacob Wyngaard" userId="6181fcd471e98458" providerId="LiveId" clId="{788BA123-62C9-4DDC-86E5-A6BCA4600216}" dt="2026-02-17T03:05:46.434" v="2799" actId="47"/>
-        <pc:sldMkLst>
-          <pc:docMk/>
-          <pc:sldMk cId="1116112418" sldId="256"/>
-        </pc:sldMkLst>
-      </pc:sldChg>
       <pc:sldChg chg="addSp delSp modSp add mod">
         <pc:chgData name="Jacob Wyngaard" userId="6181fcd471e98458" providerId="LiveId" clId="{788BA123-62C9-4DDC-86E5-A6BCA4600216}" dt="2026-02-17T00:40:43.131" v="574" actId="1036"/>
         <pc:sldMkLst>
@@ -185,14 +178,6 @@
             <ac:spMk id="5" creationId="{36C6877F-6D49-54B4-214A-08A9DB3A99DB}"/>
           </ac:spMkLst>
         </pc:spChg>
-        <pc:spChg chg="del mod">
-          <ac:chgData name="Jacob Wyngaard" userId="6181fcd471e98458" providerId="LiveId" clId="{788BA123-62C9-4DDC-86E5-A6BCA4600216}" dt="2026-02-17T00:38:04.660" v="274" actId="21"/>
-          <ac:spMkLst>
-            <pc:docMk/>
-            <pc:sldMk cId="285127923" sldId="285"/>
-            <ac:spMk id="6" creationId="{A384FA5A-7307-1855-21D3-AD0D79A01D7F}"/>
-          </ac:spMkLst>
-        </pc:spChg>
         <pc:picChg chg="add mod">
           <ac:chgData name="Jacob Wyngaard" userId="6181fcd471e98458" providerId="LiveId" clId="{788BA123-62C9-4DDC-86E5-A6BCA4600216}" dt="2026-02-17T00:40:43.131" v="574" actId="1036"/>
           <ac:picMkLst>
@@ -202,33 +187,20 @@
           </ac:picMkLst>
         </pc:picChg>
       </pc:sldChg>
-      <pc:sldChg chg="del">
-        <pc:chgData name="Jacob Wyngaard" userId="6181fcd471e98458" providerId="LiveId" clId="{788BA123-62C9-4DDC-86E5-A6BCA4600216}" dt="2026-02-17T02:59:31.778" v="2472" actId="47"/>
+      <pc:sldChg chg="modSp mod">
+        <pc:chgData name="Jacob Wyngaard" userId="6181fcd471e98458" providerId="LiveId" clId="{788BA123-62C9-4DDC-86E5-A6BCA4600216}" dt="2026-02-23T16:27:20.536" v="2960" actId="1076"/>
         <pc:sldMkLst>
           <pc:docMk/>
-          <pc:sldMk cId="2262398433" sldId="286"/>
+          <pc:sldMk cId="448432070" sldId="303"/>
         </pc:sldMkLst>
-      </pc:sldChg>
-      <pc:sldChg chg="del">
-        <pc:chgData name="Jacob Wyngaard" userId="6181fcd471e98458" providerId="LiveId" clId="{788BA123-62C9-4DDC-86E5-A6BCA4600216}" dt="2026-02-17T02:59:31.778" v="2472" actId="47"/>
-        <pc:sldMkLst>
-          <pc:docMk/>
-          <pc:sldMk cId="672059297" sldId="287"/>
-        </pc:sldMkLst>
-      </pc:sldChg>
-      <pc:sldChg chg="del">
-        <pc:chgData name="Jacob Wyngaard" userId="6181fcd471e98458" providerId="LiveId" clId="{788BA123-62C9-4DDC-86E5-A6BCA4600216}" dt="2026-02-17T02:59:31.778" v="2472" actId="47"/>
-        <pc:sldMkLst>
-          <pc:docMk/>
-          <pc:sldMk cId="3751011158" sldId="288"/>
-        </pc:sldMkLst>
-      </pc:sldChg>
-      <pc:sldChg chg="del">
-        <pc:chgData name="Jacob Wyngaard" userId="6181fcd471e98458" providerId="LiveId" clId="{788BA123-62C9-4DDC-86E5-A6BCA4600216}" dt="2026-02-17T02:59:31.778" v="2472" actId="47"/>
-        <pc:sldMkLst>
-          <pc:docMk/>
-          <pc:sldMk cId="1373182850" sldId="309"/>
-        </pc:sldMkLst>
+        <pc:spChg chg="mod">
+          <ac:chgData name="Jacob Wyngaard" userId="6181fcd471e98458" providerId="LiveId" clId="{788BA123-62C9-4DDC-86E5-A6BCA4600216}" dt="2026-02-23T16:27:20.536" v="2960" actId="1076"/>
+          <ac:spMkLst>
+            <pc:docMk/>
+            <pc:sldMk cId="448432070" sldId="303"/>
+            <ac:spMk id="30" creationId="{2677D931-5831-EF5C-82D1-F8CD04DAF1A4}"/>
+          </ac:spMkLst>
+        </pc:spChg>
       </pc:sldChg>
       <pc:sldChg chg="addSp modSp add mod">
         <pc:chgData name="Jacob Wyngaard" userId="6181fcd471e98458" providerId="LiveId" clId="{788BA123-62C9-4DDC-86E5-A6BCA4600216}" dt="2026-02-17T00:47:31.034" v="1096" actId="113"/>
@@ -299,14 +271,6 @@
             <ac:spMk id="9" creationId="{1EB60950-632A-C01F-E57B-503A9D1D48A2}"/>
           </ac:spMkLst>
         </pc:spChg>
-        <pc:spChg chg="add del mod">
-          <ac:chgData name="Jacob Wyngaard" userId="6181fcd471e98458" providerId="LiveId" clId="{788BA123-62C9-4DDC-86E5-A6BCA4600216}" dt="2026-02-17T01:03:02.649" v="1766" actId="478"/>
-          <ac:spMkLst>
-            <pc:docMk/>
-            <pc:sldMk cId="1526910787" sldId="311"/>
-            <ac:spMk id="10" creationId="{98078495-1F3D-5485-3A92-DB0E086BB750}"/>
-          </ac:spMkLst>
-        </pc:spChg>
         <pc:graphicFrameChg chg="add mod modGraphic">
           <ac:chgData name="Jacob Wyngaard" userId="6181fcd471e98458" providerId="LiveId" clId="{788BA123-62C9-4DDC-86E5-A6BCA4600216}" dt="2026-02-17T00:59:32.949" v="1441" actId="20577"/>
           <ac:graphicFrameMkLst>
@@ -315,20 +279,6 @@
             <ac:graphicFrameMk id="6" creationId="{6E92FFE0-1A7C-DE7D-20AF-CB543C78CBB9}"/>
           </ac:graphicFrameMkLst>
         </pc:graphicFrameChg>
-      </pc:sldChg>
-      <pc:sldChg chg="add del">
-        <pc:chgData name="Jacob Wyngaard" userId="6181fcd471e98458" providerId="LiveId" clId="{788BA123-62C9-4DDC-86E5-A6BCA4600216}" dt="2026-02-17T02:59:31.778" v="2472" actId="47"/>
-        <pc:sldMkLst>
-          <pc:docMk/>
-          <pc:sldMk cId="521476072" sldId="312"/>
-        </pc:sldMkLst>
-      </pc:sldChg>
-      <pc:sldChg chg="add del">
-        <pc:chgData name="Jacob Wyngaard" userId="6181fcd471e98458" providerId="LiveId" clId="{788BA123-62C9-4DDC-86E5-A6BCA4600216}" dt="2026-02-17T02:59:31.778" v="2472" actId="47"/>
-        <pc:sldMkLst>
-          <pc:docMk/>
-          <pc:sldMk cId="3190315159" sldId="313"/>
-        </pc:sldMkLst>
       </pc:sldChg>
       <pc:sldChg chg="addSp delSp modSp add mod">
         <pc:chgData name="Jacob Wyngaard" userId="6181fcd471e98458" providerId="LiveId" clId="{788BA123-62C9-4DDC-86E5-A6BCA4600216}" dt="2026-02-17T02:47:34.464" v="2266" actId="1076"/>
@@ -342,54 +292,6 @@
             <pc:docMk/>
             <pc:sldMk cId="4289787205" sldId="314"/>
             <ac:spMk id="4" creationId="{C71296F8-B1AF-2C04-97DA-D66B520C3840}"/>
-          </ac:spMkLst>
-        </pc:spChg>
-        <pc:spChg chg="del mod">
-          <ac:chgData name="Jacob Wyngaard" userId="6181fcd471e98458" providerId="LiveId" clId="{788BA123-62C9-4DDC-86E5-A6BCA4600216}" dt="2026-02-17T01:17:16.525" v="2170" actId="478"/>
-          <ac:spMkLst>
-            <pc:docMk/>
-            <pc:sldMk cId="4289787205" sldId="314"/>
-            <ac:spMk id="5" creationId="{AFC120E8-7E9B-19D3-E4ED-1ECF15AC6CBC}"/>
-          </ac:spMkLst>
-        </pc:spChg>
-        <pc:spChg chg="add del mod">
-          <ac:chgData name="Jacob Wyngaard" userId="6181fcd471e98458" providerId="LiveId" clId="{788BA123-62C9-4DDC-86E5-A6BCA4600216}" dt="2026-02-17T02:42:49.424" v="2187" actId="478"/>
-          <ac:spMkLst>
-            <pc:docMk/>
-            <pc:sldMk cId="4289787205" sldId="314"/>
-            <ac:spMk id="7" creationId="{F874FC4B-01C9-CB88-5521-1397662F17C9}"/>
-          </ac:spMkLst>
-        </pc:spChg>
-        <pc:spChg chg="add del mod">
-          <ac:chgData name="Jacob Wyngaard" userId="6181fcd471e98458" providerId="LiveId" clId="{788BA123-62C9-4DDC-86E5-A6BCA4600216}" dt="2026-02-17T01:18:08.029" v="2173" actId="478"/>
-          <ac:spMkLst>
-            <pc:docMk/>
-            <pc:sldMk cId="4289787205" sldId="314"/>
-            <ac:spMk id="9" creationId="{996485F5-49F5-F702-8ED5-93A0830C0176}"/>
-          </ac:spMkLst>
-        </pc:spChg>
-        <pc:spChg chg="add del mod">
-          <ac:chgData name="Jacob Wyngaard" userId="6181fcd471e98458" providerId="LiveId" clId="{788BA123-62C9-4DDC-86E5-A6BCA4600216}" dt="2026-02-17T01:18:14.124" v="2175" actId="478"/>
-          <ac:spMkLst>
-            <pc:docMk/>
-            <pc:sldMk cId="4289787205" sldId="314"/>
-            <ac:spMk id="10" creationId="{40B0BE71-6A68-9945-3BD0-AB759C99E5BE}"/>
-          </ac:spMkLst>
-        </pc:spChg>
-        <pc:spChg chg="add del mod">
-          <ac:chgData name="Jacob Wyngaard" userId="6181fcd471e98458" providerId="LiveId" clId="{788BA123-62C9-4DDC-86E5-A6BCA4600216}" dt="2026-02-17T01:18:14.124" v="2175" actId="478"/>
-          <ac:spMkLst>
-            <pc:docMk/>
-            <pc:sldMk cId="4289787205" sldId="314"/>
-            <ac:spMk id="11" creationId="{334706CE-FA27-CC6A-CCF8-4648A97B1FEC}"/>
-          </ac:spMkLst>
-        </pc:spChg>
-        <pc:spChg chg="add del mod">
-          <ac:chgData name="Jacob Wyngaard" userId="6181fcd471e98458" providerId="LiveId" clId="{788BA123-62C9-4DDC-86E5-A6BCA4600216}" dt="2026-02-17T01:18:14.124" v="2175" actId="478"/>
-          <ac:spMkLst>
-            <pc:docMk/>
-            <pc:sldMk cId="4289787205" sldId="314"/>
-            <ac:spMk id="12" creationId="{3DB3AD29-364A-0EE4-A655-8037DD304F75}"/>
           </ac:spMkLst>
         </pc:spChg>
         <pc:spChg chg="add mod">
@@ -432,30 +334,6 @@
             <ac:spMk id="19" creationId="{9AB1CB42-0601-C09F-A4B7-F3FDE2046A9C}"/>
           </ac:spMkLst>
         </pc:spChg>
-        <pc:graphicFrameChg chg="add del mod modGraphic">
-          <ac:chgData name="Jacob Wyngaard" userId="6181fcd471e98458" providerId="LiveId" clId="{788BA123-62C9-4DDC-86E5-A6BCA4600216}" dt="2026-02-17T02:42:48.355" v="2186" actId="478"/>
-          <ac:graphicFrameMkLst>
-            <pc:docMk/>
-            <pc:sldMk cId="4289787205" sldId="314"/>
-            <ac:graphicFrameMk id="8" creationId="{1F48F3D3-4A41-04EC-3F6D-792B774BF6CE}"/>
-          </ac:graphicFrameMkLst>
-        </pc:graphicFrameChg>
-        <pc:picChg chg="add del mod">
-          <ac:chgData name="Jacob Wyngaard" userId="6181fcd471e98458" providerId="LiveId" clId="{788BA123-62C9-4DDC-86E5-A6BCA4600216}" dt="2026-02-17T01:09:35.352" v="1947" actId="478"/>
-          <ac:picMkLst>
-            <pc:docMk/>
-            <pc:sldMk cId="4289787205" sldId="314"/>
-            <ac:picMk id="6" creationId="{97B12504-4B27-11EB-5CB8-F2A4300BB6C5}"/>
-          </ac:picMkLst>
-        </pc:picChg>
-        <pc:picChg chg="add del mod">
-          <ac:chgData name="Jacob Wyngaard" userId="6181fcd471e98458" providerId="LiveId" clId="{788BA123-62C9-4DDC-86E5-A6BCA4600216}" dt="2026-02-17T02:42:39.715" v="2183" actId="478"/>
-          <ac:picMkLst>
-            <pc:docMk/>
-            <pc:sldMk cId="4289787205" sldId="314"/>
-            <ac:picMk id="13" creationId="{689FD750-3A27-92D4-11B2-4E575711A97E}"/>
-          </ac:picMkLst>
-        </pc:picChg>
         <pc:picChg chg="add mod modCrop">
           <ac:chgData name="Jacob Wyngaard" userId="6181fcd471e98458" providerId="LiveId" clId="{788BA123-62C9-4DDC-86E5-A6BCA4600216}" dt="2026-02-17T02:47:18.715" v="2263" actId="1076"/>
           <ac:picMkLst>
@@ -464,14 +342,6 @@
             <ac:picMk id="14" creationId="{6A57A076-8A60-28B3-6F11-4E66E029C000}"/>
           </ac:picMkLst>
         </pc:picChg>
-        <pc:cxnChg chg="add del">
-          <ac:chgData name="Jacob Wyngaard" userId="6181fcd471e98458" providerId="LiveId" clId="{788BA123-62C9-4DDC-86E5-A6BCA4600216}" dt="2026-02-17T02:46:20.167" v="2251" actId="478"/>
-          <ac:cxnSpMkLst>
-            <pc:docMk/>
-            <pc:sldMk cId="4289787205" sldId="314"/>
-            <ac:cxnSpMk id="21" creationId="{3B1071E9-004B-DC21-9ED1-25766BE905E1}"/>
-          </ac:cxnSpMkLst>
-        </pc:cxnChg>
         <pc:cxnChg chg="add mod">
           <ac:chgData name="Jacob Wyngaard" userId="6181fcd471e98458" providerId="LiveId" clId="{788BA123-62C9-4DDC-86E5-A6BCA4600216}" dt="2026-02-17T02:47:34.464" v="2266" actId="1076"/>
           <ac:cxnSpMkLst>
@@ -542,14 +412,6 @@
           </ac:spMkLst>
         </pc:spChg>
         <pc:spChg chg="add mod">
-          <ac:chgData name="Jacob Wyngaard" userId="6181fcd471e98458" providerId="LiveId" clId="{788BA123-62C9-4DDC-86E5-A6BCA4600216}" dt="2026-02-17T02:56:46.548" v="2380" actId="1076"/>
-          <ac:spMkLst>
-            <pc:docMk/>
-            <pc:sldMk cId="1602887601" sldId="317"/>
-            <ac:spMk id="8" creationId="{D5B88572-17E8-0CCC-341C-9C6F529A82AC}"/>
-          </ac:spMkLst>
-        </pc:spChg>
-        <pc:spChg chg="add mod">
           <ac:chgData name="Jacob Wyngaard" userId="6181fcd471e98458" providerId="LiveId" clId="{788BA123-62C9-4DDC-86E5-A6BCA4600216}" dt="2026-02-17T02:57:09.964" v="2390" actId="20577"/>
           <ac:spMkLst>
             <pc:docMk/>
@@ -581,44 +443,12 @@
             <ac:spMk id="12" creationId="{C5911650-0D0B-41C7-861A-2147F49B422C}"/>
           </ac:spMkLst>
         </pc:spChg>
-        <pc:spChg chg="del">
-          <ac:chgData name="Jacob Wyngaard" userId="6181fcd471e98458" providerId="LiveId" clId="{788BA123-62C9-4DDC-86E5-A6BCA4600216}" dt="2026-02-17T02:55:09.413" v="2273" actId="478"/>
-          <ac:spMkLst>
-            <pc:docMk/>
-            <pc:sldMk cId="1602887601" sldId="317"/>
-            <ac:spMk id="15" creationId="{CB83E748-08FE-061A-A602-D405B9F314DF}"/>
-          </ac:spMkLst>
-        </pc:spChg>
-        <pc:spChg chg="del mod">
-          <ac:chgData name="Jacob Wyngaard" userId="6181fcd471e98458" providerId="LiveId" clId="{788BA123-62C9-4DDC-86E5-A6BCA4600216}" dt="2026-02-17T02:55:07.698" v="2270" actId="478"/>
-          <ac:spMkLst>
-            <pc:docMk/>
-            <pc:sldMk cId="1602887601" sldId="317"/>
-            <ac:spMk id="16" creationId="{80789A1E-7A23-F778-9ED4-DF66B4A596BD}"/>
-          </ac:spMkLst>
-        </pc:spChg>
         <pc:spChg chg="mod">
           <ac:chgData name="Jacob Wyngaard" userId="6181fcd471e98458" providerId="LiveId" clId="{788BA123-62C9-4DDC-86E5-A6BCA4600216}" dt="2026-02-17T02:55:34.807" v="2334" actId="1076"/>
           <ac:spMkLst>
             <pc:docMk/>
             <pc:sldMk cId="1602887601" sldId="317"/>
             <ac:spMk id="17" creationId="{C7ACE0FD-EC29-0E01-0D9F-BE276085456E}"/>
-          </ac:spMkLst>
-        </pc:spChg>
-        <pc:spChg chg="del">
-          <ac:chgData name="Jacob Wyngaard" userId="6181fcd471e98458" providerId="LiveId" clId="{788BA123-62C9-4DDC-86E5-A6BCA4600216}" dt="2026-02-17T02:55:08.699" v="2272" actId="478"/>
-          <ac:spMkLst>
-            <pc:docMk/>
-            <pc:sldMk cId="1602887601" sldId="317"/>
-            <ac:spMk id="18" creationId="{EC7F4ED6-3928-0C1C-FA01-C8B2F58A0E7D}"/>
-          </ac:spMkLst>
-        </pc:spChg>
-        <pc:spChg chg="del">
-          <ac:chgData name="Jacob Wyngaard" userId="6181fcd471e98458" providerId="LiveId" clId="{788BA123-62C9-4DDC-86E5-A6BCA4600216}" dt="2026-02-17T02:55:08.261" v="2271" actId="478"/>
-          <ac:spMkLst>
-            <pc:docMk/>
-            <pc:sldMk cId="1602887601" sldId="317"/>
-            <ac:spMk id="19" creationId="{7B47185A-10B5-8E6B-4F6A-39B8C96F2741}"/>
           </ac:spMkLst>
         </pc:spChg>
         <pc:graphicFrameChg chg="add mod modGraphic">
@@ -629,22 +459,6 @@
             <ac:graphicFrameMk id="6" creationId="{6312254D-BC3E-3702-0115-0736730735C9}"/>
           </ac:graphicFrameMkLst>
         </pc:graphicFrameChg>
-        <pc:picChg chg="del">
-          <ac:chgData name="Jacob Wyngaard" userId="6181fcd471e98458" providerId="LiveId" clId="{788BA123-62C9-4DDC-86E5-A6BCA4600216}" dt="2026-02-17T02:55:05.941" v="2268" actId="478"/>
-          <ac:picMkLst>
-            <pc:docMk/>
-            <pc:sldMk cId="1602887601" sldId="317"/>
-            <ac:picMk id="14" creationId="{5EC2A566-8DA5-1317-C0A8-0800530AC441}"/>
-          </ac:picMkLst>
-        </pc:picChg>
-        <pc:cxnChg chg="del">
-          <ac:chgData name="Jacob Wyngaard" userId="6181fcd471e98458" providerId="LiveId" clId="{788BA123-62C9-4DDC-86E5-A6BCA4600216}" dt="2026-02-17T02:55:10.198" v="2274" actId="478"/>
-          <ac:cxnSpMkLst>
-            <pc:docMk/>
-            <pc:sldMk cId="1602887601" sldId="317"/>
-            <ac:cxnSpMk id="22" creationId="{CB56F07E-BA6C-792C-00D1-E001F60C5083}"/>
-          </ac:cxnSpMkLst>
-        </pc:cxnChg>
       </pc:sldChg>
       <pc:sldChg chg="addSp delSp modSp add mod">
         <pc:chgData name="Jacob Wyngaard" userId="6181fcd471e98458" providerId="LiveId" clId="{788BA123-62C9-4DDC-86E5-A6BCA4600216}" dt="2026-02-17T03:13:41.011" v="2959" actId="14100"/>
@@ -658,22 +472,6 @@
             <pc:docMk/>
             <pc:sldMk cId="1156055420" sldId="318"/>
             <ac:spMk id="4" creationId="{979E6784-EE2F-1A70-F6C4-BBA09F8176FE}"/>
-          </ac:spMkLst>
-        </pc:spChg>
-        <pc:spChg chg="del">
-          <ac:chgData name="Jacob Wyngaard" userId="6181fcd471e98458" providerId="LiveId" clId="{788BA123-62C9-4DDC-86E5-A6BCA4600216}" dt="2026-02-17T03:12:26.042" v="2940" actId="478"/>
-          <ac:spMkLst>
-            <pc:docMk/>
-            <pc:sldMk cId="1156055420" sldId="318"/>
-            <ac:spMk id="5" creationId="{3EC6562D-3E6C-D7B7-DC4A-DD0D5761547A}"/>
-          </ac:spMkLst>
-        </pc:spChg>
-        <pc:spChg chg="del">
-          <ac:chgData name="Jacob Wyngaard" userId="6181fcd471e98458" providerId="LiveId" clId="{788BA123-62C9-4DDC-86E5-A6BCA4600216}" dt="2026-02-17T03:12:27.303" v="2941" actId="478"/>
-          <ac:spMkLst>
-            <pc:docMk/>
-            <pc:sldMk cId="1156055420" sldId="318"/>
-            <ac:spMk id="7" creationId="{24C691ED-6B7A-02D9-0229-1907BC81D267}"/>
           </ac:spMkLst>
         </pc:spChg>
         <pc:spChg chg="add mod">
@@ -788,7 +586,7 @@
           <a:p>
             <a:fld id="{351EB116-73EE-4936-876D-CA6054346043}" type="datetimeFigureOut">
               <a:rPr lang="en-US" smtClean="0"/>
-              <a:t>2/16/2026</a:t>
+              <a:t>2/23/2026</a:t>
             </a:fld>
             <a:endParaRPr lang="en-US"/>
           </a:p>
@@ -4136,7 +3934,7 @@
           <a:p>
             <a:fld id="{4E9DFCA7-2E84-49E5-A4F2-77D92A699F3D}" type="datetimeFigureOut">
               <a:rPr lang="en-US" smtClean="0"/>
-              <a:t>2/16/2026</a:t>
+              <a:t>2/23/2026</a:t>
             </a:fld>
             <a:endParaRPr lang="en-US"/>
           </a:p>
@@ -4334,7 +4132,7 @@
           <a:p>
             <a:fld id="{4E9DFCA7-2E84-49E5-A4F2-77D92A699F3D}" type="datetimeFigureOut">
               <a:rPr lang="en-US" smtClean="0"/>
-              <a:t>2/16/2026</a:t>
+              <a:t>2/23/2026</a:t>
             </a:fld>
             <a:endParaRPr lang="en-US"/>
           </a:p>
@@ -4542,7 +4340,7 @@
           <a:p>
             <a:fld id="{4E9DFCA7-2E84-49E5-A4F2-77D92A699F3D}" type="datetimeFigureOut">
               <a:rPr lang="en-US" smtClean="0"/>
-              <a:t>2/16/2026</a:t>
+              <a:t>2/23/2026</a:t>
             </a:fld>
             <a:endParaRPr lang="en-US"/>
           </a:p>
@@ -4740,7 +4538,7 @@
           <a:p>
             <a:fld id="{4E9DFCA7-2E84-49E5-A4F2-77D92A699F3D}" type="datetimeFigureOut">
               <a:rPr lang="en-US" smtClean="0"/>
-              <a:t>2/16/2026</a:t>
+              <a:t>2/23/2026</a:t>
             </a:fld>
             <a:endParaRPr lang="en-US"/>
           </a:p>
@@ -5015,7 +4813,7 @@
           <a:p>
             <a:fld id="{4E9DFCA7-2E84-49E5-A4F2-77D92A699F3D}" type="datetimeFigureOut">
               <a:rPr lang="en-US" smtClean="0"/>
-              <a:t>2/16/2026</a:t>
+              <a:t>2/23/2026</a:t>
             </a:fld>
             <a:endParaRPr lang="en-US"/>
           </a:p>
@@ -5280,7 +5078,7 @@
           <a:p>
             <a:fld id="{4E9DFCA7-2E84-49E5-A4F2-77D92A699F3D}" type="datetimeFigureOut">
               <a:rPr lang="en-US" smtClean="0"/>
-              <a:t>2/16/2026</a:t>
+              <a:t>2/23/2026</a:t>
             </a:fld>
             <a:endParaRPr lang="en-US"/>
           </a:p>
@@ -5692,7 +5490,7 @@
           <a:p>
             <a:fld id="{4E9DFCA7-2E84-49E5-A4F2-77D92A699F3D}" type="datetimeFigureOut">
               <a:rPr lang="en-US" smtClean="0"/>
-              <a:t>2/16/2026</a:t>
+              <a:t>2/23/2026</a:t>
             </a:fld>
             <a:endParaRPr lang="en-US"/>
           </a:p>
@@ -5833,7 +5631,7 @@
           <a:p>
             <a:fld id="{4E9DFCA7-2E84-49E5-A4F2-77D92A699F3D}" type="datetimeFigureOut">
               <a:rPr lang="en-US" smtClean="0"/>
-              <a:t>2/16/2026</a:t>
+              <a:t>2/23/2026</a:t>
             </a:fld>
             <a:endParaRPr lang="en-US"/>
           </a:p>
@@ -5946,7 +5744,7 @@
           <a:p>
             <a:fld id="{4E9DFCA7-2E84-49E5-A4F2-77D92A699F3D}" type="datetimeFigureOut">
               <a:rPr lang="en-US" smtClean="0"/>
-              <a:t>2/16/2026</a:t>
+              <a:t>2/23/2026</a:t>
             </a:fld>
             <a:endParaRPr lang="en-US"/>
           </a:p>
@@ -6257,7 +6055,7 @@
           <a:p>
             <a:fld id="{4E9DFCA7-2E84-49E5-A4F2-77D92A699F3D}" type="datetimeFigureOut">
               <a:rPr lang="en-US" smtClean="0"/>
-              <a:t>2/16/2026</a:t>
+              <a:t>2/23/2026</a:t>
             </a:fld>
             <a:endParaRPr lang="en-US"/>
           </a:p>
@@ -6545,7 +6343,7 @@
           <a:p>
             <a:fld id="{4E9DFCA7-2E84-49E5-A4F2-77D92A699F3D}" type="datetimeFigureOut">
               <a:rPr lang="en-US" smtClean="0"/>
-              <a:t>2/16/2026</a:t>
+              <a:t>2/23/2026</a:t>
             </a:fld>
             <a:endParaRPr lang="en-US"/>
           </a:p>
@@ -6786,7 +6584,7 @@
           <a:p>
             <a:fld id="{4E9DFCA7-2E84-49E5-A4F2-77D92A699F3D}" type="datetimeFigureOut">
               <a:rPr lang="en-US" smtClean="0"/>
-              <a:t>2/16/2026</a:t>
+              <a:t>2/23/2026</a:t>
             </a:fld>
             <a:endParaRPr lang="en-US"/>
           </a:p>
@@ -13757,8 +13555,8 @@
           </p:sp>
         </mc:Fallback>
       </mc:AlternateContent>
-      <mc:AlternateContent xmlns:mc="http://schemas.openxmlformats.org/markup-compatibility/2006" xmlns:a14="http://schemas.microsoft.com/office/drawing/2010/main">
-        <mc:Choice Requires="a14">
+      <mc:AlternateContent xmlns:mc="http://schemas.openxmlformats.org/markup-compatibility/2006">
+        <mc:Choice xmlns:a14="http://schemas.microsoft.com/office/drawing/2010/main" Requires="a14">
           <p:sp>
             <p:nvSpPr>
               <p:cNvPr id="30" name="TextBox 29">
@@ -13773,7 +13571,7 @@
             </p:nvSpPr>
             <p:spPr>
               <a:xfrm>
-                <a:off x="1189703" y="4618606"/>
+                <a:off x="792826" y="4535581"/>
                 <a:ext cx="8862452" cy="468654"/>
               </a:xfrm>
               <a:prstGeom prst="rect">
@@ -13982,7 +13780,7 @@
             </p:txBody>
           </p:sp>
         </mc:Choice>
-        <mc:Fallback xmlns="">
+        <mc:Fallback>
           <p:sp>
             <p:nvSpPr>
               <p:cNvPr id="30" name="TextBox 29">
@@ -13999,7 +13797,7 @@
             </p:nvSpPr>
             <p:spPr>
               <a:xfrm>
-                <a:off x="1189703" y="4618606"/>
+                <a:off x="792826" y="4535581"/>
                 <a:ext cx="8862452" cy="468654"/>
               </a:xfrm>
               <a:prstGeom prst="rect">
@@ -23469,8 +23267,8 @@
           </a:p>
         </p:txBody>
       </p:sp>
-      <mc:AlternateContent xmlns:mc="http://schemas.openxmlformats.org/markup-compatibility/2006">
-        <mc:Choice xmlns:a14="http://schemas.microsoft.com/office/drawing/2010/main" Requires="a14">
+      <mc:AlternateContent xmlns:mc="http://schemas.openxmlformats.org/markup-compatibility/2006" xmlns:a14="http://schemas.microsoft.com/office/drawing/2010/main">
+        <mc:Choice Requires="a14">
           <p:sp>
             <p:nvSpPr>
               <p:cNvPr id="5" name="TextBox 4">
@@ -23979,7 +23777,7 @@
             </p:txBody>
           </p:sp>
         </mc:Choice>
-        <mc:Fallback>
+        <mc:Fallback xmlns="">
           <p:sp>
             <p:nvSpPr>
               <p:cNvPr id="5" name="TextBox 4">
@@ -24024,8 +23822,8 @@
           </p:sp>
         </mc:Fallback>
       </mc:AlternateContent>
-      <mc:AlternateContent xmlns:mc="http://schemas.openxmlformats.org/markup-compatibility/2006">
-        <mc:Choice xmlns:a14="http://schemas.microsoft.com/office/drawing/2010/main" Requires="a14">
+      <mc:AlternateContent xmlns:mc="http://schemas.openxmlformats.org/markup-compatibility/2006" xmlns:a14="http://schemas.microsoft.com/office/drawing/2010/main">
+        <mc:Choice Requires="a14">
           <p:sp>
             <p:nvSpPr>
               <p:cNvPr id="6" name="TextBox 5">
@@ -24264,7 +24062,7 @@
             </p:txBody>
           </p:sp>
         </mc:Choice>
-        <mc:Fallback>
+        <mc:Fallback xmlns="">
           <p:sp>
             <p:nvSpPr>
               <p:cNvPr id="6" name="TextBox 5">
@@ -24545,8 +24343,8 @@
           </a:p>
         </p:txBody>
       </p:sp>
-      <mc:AlternateContent xmlns:mc="http://schemas.openxmlformats.org/markup-compatibility/2006">
-        <mc:Choice xmlns:a14="http://schemas.microsoft.com/office/drawing/2010/main" Requires="a14">
+      <mc:AlternateContent xmlns:mc="http://schemas.openxmlformats.org/markup-compatibility/2006" xmlns:a14="http://schemas.microsoft.com/office/drawing/2010/main">
+        <mc:Choice Requires="a14">
           <p:graphicFrame>
             <p:nvGraphicFramePr>
               <p:cNvPr id="6" name="Table 5">
@@ -26357,7 +26155,7 @@
             </a:graphic>
           </p:graphicFrame>
         </mc:Choice>
-        <mc:Fallback>
+        <mc:Fallback xmlns="">
           <p:graphicFrame>
             <p:nvGraphicFramePr>
               <p:cNvPr id="6" name="Table 5">
@@ -27611,8 +27409,8 @@
           </p:graphicFrame>
         </mc:Fallback>
       </mc:AlternateContent>
-      <mc:AlternateContent xmlns:mc="http://schemas.openxmlformats.org/markup-compatibility/2006">
-        <mc:Choice xmlns:a14="http://schemas.microsoft.com/office/drawing/2010/main" Requires="a14">
+      <mc:AlternateContent xmlns:mc="http://schemas.openxmlformats.org/markup-compatibility/2006" xmlns:a14="http://schemas.microsoft.com/office/drawing/2010/main">
+        <mc:Choice Requires="a14">
           <p:sp>
             <p:nvSpPr>
               <p:cNvPr id="8" name="TextBox 7">
@@ -27663,7 +27461,7 @@
             </p:txBody>
           </p:sp>
         </mc:Choice>
-        <mc:Fallback>
+        <mc:Fallback xmlns="">
           <p:sp>
             <p:nvSpPr>
               <p:cNvPr id="8" name="TextBox 7">
@@ -28035,8 +27833,8 @@
           </a:p>
         </p:txBody>
       </p:sp>
-      <mc:AlternateContent xmlns:mc="http://schemas.openxmlformats.org/markup-compatibility/2006">
-        <mc:Choice xmlns:a14="http://schemas.microsoft.com/office/drawing/2010/main" Requires="a14">
+      <mc:AlternateContent xmlns:mc="http://schemas.openxmlformats.org/markup-compatibility/2006" xmlns:a14="http://schemas.microsoft.com/office/drawing/2010/main">
+        <mc:Choice Requires="a14">
           <p:graphicFrame>
             <p:nvGraphicFramePr>
               <p:cNvPr id="8" name="Table 7">
@@ -29841,7 +29639,7 @@
             </a:graphic>
           </p:graphicFrame>
         </mc:Choice>
-        <mc:Fallback>
+        <mc:Fallback xmlns="">
           <p:graphicFrame>
             <p:nvGraphicFramePr>
               <p:cNvPr id="8" name="Table 7">
@@ -31089,8 +30887,8 @@
           </p:graphicFrame>
         </mc:Fallback>
       </mc:AlternateContent>
-      <mc:AlternateContent xmlns:mc="http://schemas.openxmlformats.org/markup-compatibility/2006">
-        <mc:Choice xmlns:a14="http://schemas.microsoft.com/office/drawing/2010/main" Requires="a14">
+      <mc:AlternateContent xmlns:mc="http://schemas.openxmlformats.org/markup-compatibility/2006" xmlns:a14="http://schemas.microsoft.com/office/drawing/2010/main">
+        <mc:Choice Requires="a14">
           <p:sp>
             <p:nvSpPr>
               <p:cNvPr id="9" name="TextBox 8">
@@ -31235,7 +31033,7 @@
             </p:txBody>
           </p:sp>
         </mc:Choice>
-        <mc:Fallback>
+        <mc:Fallback xmlns="">
           <p:sp>
             <p:nvSpPr>
               <p:cNvPr id="9" name="TextBox 8">
@@ -31280,8 +31078,8 @@
           </p:sp>
         </mc:Fallback>
       </mc:AlternateContent>
-      <mc:AlternateContent xmlns:mc="http://schemas.openxmlformats.org/markup-compatibility/2006">
-        <mc:Choice xmlns:a14="http://schemas.microsoft.com/office/drawing/2010/main" Requires="a14">
+      <mc:AlternateContent xmlns:mc="http://schemas.openxmlformats.org/markup-compatibility/2006" xmlns:a14="http://schemas.microsoft.com/office/drawing/2010/main">
+        <mc:Choice Requires="a14">
           <p:sp>
             <p:nvSpPr>
               <p:cNvPr id="10" name="TextBox 9">
@@ -31455,7 +31253,7 @@
             </p:txBody>
           </p:sp>
         </mc:Choice>
-        <mc:Fallback>
+        <mc:Fallback xmlns="">
           <p:sp>
             <p:nvSpPr>
               <p:cNvPr id="10" name="TextBox 9">
@@ -31500,8 +31298,8 @@
           </p:sp>
         </mc:Fallback>
       </mc:AlternateContent>
-      <mc:AlternateContent xmlns:mc="http://schemas.openxmlformats.org/markup-compatibility/2006">
-        <mc:Choice xmlns:a14="http://schemas.microsoft.com/office/drawing/2010/main" Requires="a14">
+      <mc:AlternateContent xmlns:mc="http://schemas.openxmlformats.org/markup-compatibility/2006" xmlns:a14="http://schemas.microsoft.com/office/drawing/2010/main">
+        <mc:Choice Requires="a14">
           <p:sp>
             <p:nvSpPr>
               <p:cNvPr id="11" name="TextBox 10">
@@ -31651,7 +31449,7 @@
             </p:txBody>
           </p:sp>
         </mc:Choice>
-        <mc:Fallback>
+        <mc:Fallback xmlns="">
           <p:sp>
             <p:nvSpPr>
               <p:cNvPr id="11" name="TextBox 10">
@@ -31696,8 +31494,8 @@
           </p:sp>
         </mc:Fallback>
       </mc:AlternateContent>
-      <mc:AlternateContent xmlns:mc="http://schemas.openxmlformats.org/markup-compatibility/2006">
-        <mc:Choice xmlns:a14="http://schemas.microsoft.com/office/drawing/2010/main" Requires="a14">
+      <mc:AlternateContent xmlns:mc="http://schemas.openxmlformats.org/markup-compatibility/2006" xmlns:a14="http://schemas.microsoft.com/office/drawing/2010/main">
+        <mc:Choice Requires="a14">
           <p:sp>
             <p:nvSpPr>
               <p:cNvPr id="12" name="TextBox 11">
@@ -31964,7 +31762,7 @@
             </p:txBody>
           </p:sp>
         </mc:Choice>
-        <mc:Fallback>
+        <mc:Fallback xmlns="">
           <p:sp>
             <p:nvSpPr>
               <p:cNvPr id="12" name="TextBox 11">
@@ -32218,8 +32016,8 @@
           </a:prstGeom>
         </p:spPr>
       </p:pic>
-      <mc:AlternateContent xmlns:mc="http://schemas.openxmlformats.org/markup-compatibility/2006">
-        <mc:Choice xmlns:a14="http://schemas.microsoft.com/office/drawing/2010/main" Requires="a14">
+      <mc:AlternateContent xmlns:mc="http://schemas.openxmlformats.org/markup-compatibility/2006" xmlns:a14="http://schemas.microsoft.com/office/drawing/2010/main">
+        <mc:Choice Requires="a14">
           <p:sp>
             <p:nvSpPr>
               <p:cNvPr id="15" name="TextBox 14">
@@ -32386,7 +32184,7 @@
             </p:txBody>
           </p:sp>
         </mc:Choice>
-        <mc:Fallback>
+        <mc:Fallback xmlns="">
           <p:sp>
             <p:nvSpPr>
               <p:cNvPr id="15" name="TextBox 14">
@@ -32431,8 +32229,8 @@
           </p:sp>
         </mc:Fallback>
       </mc:AlternateContent>
-      <mc:AlternateContent xmlns:mc="http://schemas.openxmlformats.org/markup-compatibility/2006">
-        <mc:Choice xmlns:a14="http://schemas.microsoft.com/office/drawing/2010/main" Requires="a14">
+      <mc:AlternateContent xmlns:mc="http://schemas.openxmlformats.org/markup-compatibility/2006" xmlns:a14="http://schemas.microsoft.com/office/drawing/2010/main">
+        <mc:Choice Requires="a14">
           <p:sp>
             <p:nvSpPr>
               <p:cNvPr id="16" name="TextBox 15">
@@ -32576,7 +32374,7 @@
             </p:txBody>
           </p:sp>
         </mc:Choice>
-        <mc:Fallback>
+        <mc:Fallback xmlns="">
           <p:sp>
             <p:nvSpPr>
               <p:cNvPr id="16" name="TextBox 15">
@@ -32621,8 +32419,8 @@
           </p:sp>
         </mc:Fallback>
       </mc:AlternateContent>
-      <mc:AlternateContent xmlns:mc="http://schemas.openxmlformats.org/markup-compatibility/2006">
-        <mc:Choice xmlns:a14="http://schemas.microsoft.com/office/drawing/2010/main" Requires="a14">
+      <mc:AlternateContent xmlns:mc="http://schemas.openxmlformats.org/markup-compatibility/2006" xmlns:a14="http://schemas.microsoft.com/office/drawing/2010/main">
+        <mc:Choice Requires="a14">
           <p:sp>
             <p:nvSpPr>
               <p:cNvPr id="17" name="TextBox 16">
@@ -32883,7 +32681,7 @@
             </p:txBody>
           </p:sp>
         </mc:Choice>
-        <mc:Fallback>
+        <mc:Fallback xmlns="">
           <p:sp>
             <p:nvSpPr>
               <p:cNvPr id="17" name="TextBox 16">
@@ -33334,8 +33132,8 @@
           </a:p>
         </p:txBody>
       </p:sp>
-      <mc:AlternateContent xmlns:mc="http://schemas.openxmlformats.org/markup-compatibility/2006">
-        <mc:Choice xmlns:a14="http://schemas.microsoft.com/office/drawing/2010/main" Requires="a14">
+      <mc:AlternateContent xmlns:mc="http://schemas.openxmlformats.org/markup-compatibility/2006" xmlns:a14="http://schemas.microsoft.com/office/drawing/2010/main">
+        <mc:Choice Requires="a14">
           <p:graphicFrame>
             <p:nvGraphicFramePr>
               <p:cNvPr id="6" name="Table 5">
@@ -35146,7 +34944,7 @@
             </a:graphic>
           </p:graphicFrame>
         </mc:Choice>
-        <mc:Fallback>
+        <mc:Fallback xmlns="">
           <p:graphicFrame>
             <p:nvGraphicFramePr>
               <p:cNvPr id="6" name="Table 5">
@@ -36400,8 +36198,8 @@
           </p:graphicFrame>
         </mc:Fallback>
       </mc:AlternateContent>
-      <mc:AlternateContent xmlns:mc="http://schemas.openxmlformats.org/markup-compatibility/2006">
-        <mc:Choice xmlns:a14="http://schemas.microsoft.com/office/drawing/2010/main" Requires="a14">
+      <mc:AlternateContent xmlns:mc="http://schemas.openxmlformats.org/markup-compatibility/2006" xmlns:a14="http://schemas.microsoft.com/office/drawing/2010/main">
+        <mc:Choice Requires="a14">
           <p:sp>
             <p:nvSpPr>
               <p:cNvPr id="7" name="TextBox 6">
@@ -36537,7 +36335,7 @@
             </p:txBody>
           </p:sp>
         </mc:Choice>
-        <mc:Fallback>
+        <mc:Fallback xmlns="">
           <p:sp>
             <p:nvSpPr>
               <p:cNvPr id="7" name="TextBox 6">
@@ -36582,8 +36380,8 @@
           </p:sp>
         </mc:Fallback>
       </mc:AlternateContent>
-      <mc:AlternateContent xmlns:mc="http://schemas.openxmlformats.org/markup-compatibility/2006">
-        <mc:Choice xmlns:a14="http://schemas.microsoft.com/office/drawing/2010/main" Requires="a14">
+      <mc:AlternateContent xmlns:mc="http://schemas.openxmlformats.org/markup-compatibility/2006" xmlns:a14="http://schemas.microsoft.com/office/drawing/2010/main">
+        <mc:Choice Requires="a14">
           <p:sp>
             <p:nvSpPr>
               <p:cNvPr id="9" name="TextBox 8">
@@ -36687,14 +36485,7 @@
                         <a:latin typeface="Cambria Math" panose="02040503050406030204" pitchFamily="18" charset="0"/>
                         <a:ea typeface="Cambria Math" panose="02040503050406030204" pitchFamily="18" charset="0"/>
                       </a:rPr>
-                      <m:t>1</m:t>
-                    </m:r>
-                    <m:r>
-                      <a:rPr lang="en-US" sz="2400" b="0" i="1" smtClean="0">
-                        <a:latin typeface="Cambria Math" panose="02040503050406030204" pitchFamily="18" charset="0"/>
-                        <a:ea typeface="Cambria Math" panose="02040503050406030204" pitchFamily="18" charset="0"/>
-                      </a:rPr>
-                      <m:t>,</m:t>
+                      <m:t>1,</m:t>
                     </m:r>
                     <m:sSub>
                       <m:sSubPr>
@@ -36764,14 +36555,7 @@
                         <a:latin typeface="Cambria Math" panose="02040503050406030204" pitchFamily="18" charset="0"/>
                         <a:ea typeface="Cambria Math" panose="02040503050406030204" pitchFamily="18" charset="0"/>
                       </a:rPr>
-                      <m:t>1</m:t>
-                    </m:r>
-                    <m:r>
-                      <a:rPr lang="en-US" sz="2400" b="0" i="1" smtClean="0">
-                        <a:latin typeface="Cambria Math" panose="02040503050406030204" pitchFamily="18" charset="0"/>
-                        <a:ea typeface="Cambria Math" panose="02040503050406030204" pitchFamily="18" charset="0"/>
-                      </a:rPr>
-                      <m:t>,</m:t>
+                      <m:t>1,</m:t>
                     </m:r>
                     <m:sSub>
                       <m:sSubPr>
@@ -36850,7 +36634,7 @@
             </p:txBody>
           </p:sp>
         </mc:Choice>
-        <mc:Fallback>
+        <mc:Fallback xmlns="">
           <p:sp>
             <p:nvSpPr>
               <p:cNvPr id="9" name="TextBox 8">
@@ -36895,8 +36679,8 @@
           </p:sp>
         </mc:Fallback>
       </mc:AlternateContent>
-      <mc:AlternateContent xmlns:mc="http://schemas.openxmlformats.org/markup-compatibility/2006">
-        <mc:Choice xmlns:a14="http://schemas.microsoft.com/office/drawing/2010/main" Requires="a14">
+      <mc:AlternateContent xmlns:mc="http://schemas.openxmlformats.org/markup-compatibility/2006" xmlns:a14="http://schemas.microsoft.com/office/drawing/2010/main">
+        <mc:Choice Requires="a14">
           <p:sp>
             <p:nvSpPr>
               <p:cNvPr id="10" name="TextBox 9">
@@ -36981,13 +36765,7 @@
                         <a:rPr lang="en-US" sz="2400" b="0" i="1" smtClean="0">
                           <a:latin typeface="Cambria Math" panose="02040503050406030204" pitchFamily="18" charset="0"/>
                         </a:rPr>
-                        <m:t>+</m:t>
-                      </m:r>
-                      <m:r>
-                        <a:rPr lang="en-US" sz="2400" b="0" i="1" smtClean="0">
-                          <a:latin typeface="Cambria Math" panose="02040503050406030204" pitchFamily="18" charset="0"/>
-                        </a:rPr>
-                        <m:t>2</m:t>
+                        <m:t>+2</m:t>
                       </m:r>
                       <m:sSub>
                         <m:sSubPr>
@@ -37067,7 +36845,7 @@
             </p:txBody>
           </p:sp>
         </mc:Choice>
-        <mc:Fallback>
+        <mc:Fallback xmlns="">
           <p:sp>
             <p:nvSpPr>
               <p:cNvPr id="10" name="TextBox 9">
@@ -37112,8 +36890,8 @@
           </p:sp>
         </mc:Fallback>
       </mc:AlternateContent>
-      <mc:AlternateContent xmlns:mc="http://schemas.openxmlformats.org/markup-compatibility/2006">
-        <mc:Choice xmlns:a14="http://schemas.microsoft.com/office/drawing/2010/main" Requires="a14">
+      <mc:AlternateContent xmlns:mc="http://schemas.openxmlformats.org/markup-compatibility/2006" xmlns:a14="http://schemas.microsoft.com/office/drawing/2010/main">
+        <mc:Choice Requires="a14">
           <p:sp>
             <p:nvSpPr>
               <p:cNvPr id="11" name="TextBox 10">
@@ -37184,7 +36962,7 @@
             </p:txBody>
           </p:sp>
         </mc:Choice>
-        <mc:Fallback>
+        <mc:Fallback xmlns="">
           <p:sp>
             <p:nvSpPr>
               <p:cNvPr id="11" name="TextBox 10">
@@ -37447,8 +37225,8 @@
           </a:p>
         </p:txBody>
       </p:sp>
-      <mc:AlternateContent xmlns:mc="http://schemas.openxmlformats.org/markup-compatibility/2006">
-        <mc:Choice xmlns:a14="http://schemas.microsoft.com/office/drawing/2010/main" Requires="a14">
+      <mc:AlternateContent xmlns:mc="http://schemas.openxmlformats.org/markup-compatibility/2006" xmlns:a14="http://schemas.microsoft.com/office/drawing/2010/main">
+        <mc:Choice Requires="a14">
           <p:sp>
             <p:nvSpPr>
               <p:cNvPr id="5" name="TextBox 4">
@@ -38131,7 +37909,7 @@
             </p:txBody>
           </p:sp>
         </mc:Choice>
-        <mc:Fallback>
+        <mc:Fallback xmlns="">
           <p:sp>
             <p:nvSpPr>
               <p:cNvPr id="5" name="TextBox 4">
@@ -38176,8 +37954,8 @@
           </p:sp>
         </mc:Fallback>
       </mc:AlternateContent>
-      <mc:AlternateContent xmlns:mc="http://schemas.openxmlformats.org/markup-compatibility/2006">
-        <mc:Choice xmlns:a14="http://schemas.microsoft.com/office/drawing/2010/main" Requires="a14">
+      <mc:AlternateContent xmlns:mc="http://schemas.openxmlformats.org/markup-compatibility/2006" xmlns:a14="http://schemas.microsoft.com/office/drawing/2010/main">
+        <mc:Choice Requires="a14">
           <p:sp>
             <p:nvSpPr>
               <p:cNvPr id="7" name="TextBox 6">
@@ -38235,7 +38013,7 @@
             </p:txBody>
           </p:sp>
         </mc:Choice>
-        <mc:Fallback>
+        <mc:Fallback xmlns="">
           <p:sp>
             <p:nvSpPr>
               <p:cNvPr id="7" name="TextBox 6">

</xml_diff>